<commit_message>
Add Team 54 members, update deliverables, remove generators
- README: add Team 54 table (Tu Le, Yixin Wei, Ernesto Aguilar) with emails
- PPTX: add team member names to title slide
- PDF: regenerated with team info, removed Project Structure/Current Status sections
- Removed generate_pdf.py and generate_slides.py (one-time use)

Co-Authored-By: Claude Opus 4.6 (1M context) <noreply@anthropic.com>
</commit_message>
<xml_diff>
--- a/Spillover_Alpha_Opening.pptx
+++ b/Spillover_Alpha_Opening.pptx
@@ -5,10 +5,10 @@
     <p:sldMasterId id="2147483648" r:id="rId1"/>
   </p:sldMasterIdLst>
   <p:sldIdLst>
-    <p:sldId id="256" r:id="rId2"/>
-    <p:sldId id="257" r:id="rId3"/>
+    <p:sldId id="256" r:id="rId7"/>
+    <p:sldId id="257" r:id="rId8"/>
   </p:sldIdLst>
-  <p:sldSz cx="14630400" cy="8229600"/>
+  <p:sldSz cx="14630400" cy="8229600" type="screen4x3"/>
   <p:notesSz cx="6858000" cy="9144000"/>
   <p:defaultTextStyle>
     <a:defPPr>
@@ -105,22 +105,6 @@
       </a:defRPr>
     </a:lvl9pPr>
   </p:defaultTextStyle>
-  <p:extLst>
-    <p:ext uri="{EFAFB233-063F-42B5-8137-9DF3F51BA10A}">
-      <p15:sldGuideLst xmlns:p15="http://schemas.microsoft.com/office/powerpoint/2012/main">
-        <p15:guide id="1" orient="horz" pos="2160">
-          <p15:clr>
-            <a:srgbClr val="A4A3A4"/>
-          </p15:clr>
-        </p15:guide>
-        <p15:guide id="2" pos="2880">
-          <p15:clr>
-            <a:srgbClr val="A4A3A4"/>
-          </p15:clr>
-        </p15:guide>
-      </p15:sldGuideLst>
-    </p:ext>
-  </p:extLst>
 </p:presentation>
 </file>
 
@@ -162,9 +146,10 @@
           <a:lstStyle/>
           <a:p>
             <a:r>
-              <a:rPr lang="en-US"/>
+              <a:rPr lang="en-US" smtClean="0"/>
               <a:t>Click to edit Master title style</a:t>
             </a:r>
+            <a:endParaRPr lang="en-US"/>
           </a:p>
         </p:txBody>
       </p:sp>
@@ -280,9 +265,10 @@
           </a:lstStyle>
           <a:p>
             <a:r>
-              <a:rPr lang="en-US"/>
+              <a:rPr lang="en-US" smtClean="0"/>
               <a:t>Click to edit Master subtitle style</a:t>
             </a:r>
+            <a:endParaRPr lang="en-US"/>
           </a:p>
         </p:txBody>
       </p:sp>
@@ -303,7 +289,7 @@
           <a:p>
             <a:fld id="{5BCAD085-E8A6-8845-BD4E-CB4CCA059FC4}" type="datetimeFigureOut">
               <a:rPr lang="en-US" smtClean="0"/>
-              <a:t>4/4/26</a:t>
+              <a:t>1/27/13</a:t>
             </a:fld>
             <a:endParaRPr lang="en-US"/>
           </a:p>
@@ -397,9 +383,10 @@
           <a:lstStyle/>
           <a:p>
             <a:r>
-              <a:rPr lang="en-US"/>
+              <a:rPr lang="en-US" smtClean="0"/>
               <a:t>Click to edit Master title style</a:t>
             </a:r>
+            <a:endParaRPr lang="en-US"/>
           </a:p>
         </p:txBody>
       </p:sp>
@@ -420,37 +407,38 @@
           <a:p>
             <a:pPr lvl="0"/>
             <a:r>
-              <a:rPr lang="en-US"/>
+              <a:rPr lang="en-US" smtClean="0"/>
               <a:t>Click to edit Master text styles</a:t>
             </a:r>
           </a:p>
           <a:p>
             <a:pPr lvl="1"/>
             <a:r>
-              <a:rPr lang="en-US"/>
+              <a:rPr lang="en-US" smtClean="0"/>
               <a:t>Second level</a:t>
             </a:r>
           </a:p>
           <a:p>
             <a:pPr lvl="2"/>
             <a:r>
-              <a:rPr lang="en-US"/>
+              <a:rPr lang="en-US" smtClean="0"/>
               <a:t>Third level</a:t>
             </a:r>
           </a:p>
           <a:p>
             <a:pPr lvl="3"/>
             <a:r>
-              <a:rPr lang="en-US"/>
+              <a:rPr lang="en-US" smtClean="0"/>
               <a:t>Fourth level</a:t>
             </a:r>
           </a:p>
           <a:p>
             <a:pPr lvl="4"/>
             <a:r>
-              <a:rPr lang="en-US"/>
+              <a:rPr lang="en-US" smtClean="0"/>
               <a:t>Fifth level</a:t>
             </a:r>
+            <a:endParaRPr lang="en-US"/>
           </a:p>
         </p:txBody>
       </p:sp>
@@ -471,7 +459,7 @@
           <a:p>
             <a:fld id="{5BCAD085-E8A6-8845-BD4E-CB4CCA059FC4}" type="datetimeFigureOut">
               <a:rPr lang="en-US" smtClean="0"/>
-              <a:t>4/4/26</a:t>
+              <a:t>1/27/13</a:t>
             </a:fld>
             <a:endParaRPr lang="en-US"/>
           </a:p>
@@ -570,9 +558,10 @@
           <a:lstStyle/>
           <a:p>
             <a:r>
-              <a:rPr lang="en-US"/>
+              <a:rPr lang="en-US" smtClean="0"/>
               <a:t>Click to edit Master title style</a:t>
             </a:r>
+            <a:endParaRPr lang="en-US"/>
           </a:p>
         </p:txBody>
       </p:sp>
@@ -598,37 +587,38 @@
           <a:p>
             <a:pPr lvl="0"/>
             <a:r>
-              <a:rPr lang="en-US"/>
+              <a:rPr lang="en-US" smtClean="0"/>
               <a:t>Click to edit Master text styles</a:t>
             </a:r>
           </a:p>
           <a:p>
             <a:pPr lvl="1"/>
             <a:r>
-              <a:rPr lang="en-US"/>
+              <a:rPr lang="en-US" smtClean="0"/>
               <a:t>Second level</a:t>
             </a:r>
           </a:p>
           <a:p>
             <a:pPr lvl="2"/>
             <a:r>
-              <a:rPr lang="en-US"/>
+              <a:rPr lang="en-US" smtClean="0"/>
               <a:t>Third level</a:t>
             </a:r>
           </a:p>
           <a:p>
             <a:pPr lvl="3"/>
             <a:r>
-              <a:rPr lang="en-US"/>
+              <a:rPr lang="en-US" smtClean="0"/>
               <a:t>Fourth level</a:t>
             </a:r>
           </a:p>
           <a:p>
             <a:pPr lvl="4"/>
             <a:r>
-              <a:rPr lang="en-US"/>
+              <a:rPr lang="en-US" smtClean="0"/>
               <a:t>Fifth level</a:t>
             </a:r>
+            <a:endParaRPr lang="en-US"/>
           </a:p>
         </p:txBody>
       </p:sp>
@@ -649,7 +639,7 @@
           <a:p>
             <a:fld id="{5BCAD085-E8A6-8845-BD4E-CB4CCA059FC4}" type="datetimeFigureOut">
               <a:rPr lang="en-US" smtClean="0"/>
-              <a:t>4/4/26</a:t>
+              <a:t>1/27/13</a:t>
             </a:fld>
             <a:endParaRPr lang="en-US"/>
           </a:p>
@@ -743,9 +733,10 @@
           <a:lstStyle/>
           <a:p>
             <a:r>
-              <a:rPr lang="en-US"/>
+              <a:rPr lang="en-US" smtClean="0"/>
               <a:t>Click to edit Master title style</a:t>
             </a:r>
+            <a:endParaRPr lang="en-US"/>
           </a:p>
         </p:txBody>
       </p:sp>
@@ -766,37 +757,38 @@
           <a:p>
             <a:pPr lvl="0"/>
             <a:r>
-              <a:rPr lang="en-US"/>
+              <a:rPr lang="en-US" smtClean="0"/>
               <a:t>Click to edit Master text styles</a:t>
             </a:r>
           </a:p>
           <a:p>
             <a:pPr lvl="1"/>
             <a:r>
-              <a:rPr lang="en-US"/>
+              <a:rPr lang="en-US" smtClean="0"/>
               <a:t>Second level</a:t>
             </a:r>
           </a:p>
           <a:p>
             <a:pPr lvl="2"/>
             <a:r>
-              <a:rPr lang="en-US"/>
+              <a:rPr lang="en-US" smtClean="0"/>
               <a:t>Third level</a:t>
             </a:r>
           </a:p>
           <a:p>
             <a:pPr lvl="3"/>
             <a:r>
-              <a:rPr lang="en-US"/>
+              <a:rPr lang="en-US" smtClean="0"/>
               <a:t>Fourth level</a:t>
             </a:r>
           </a:p>
           <a:p>
             <a:pPr lvl="4"/>
             <a:r>
-              <a:rPr lang="en-US"/>
+              <a:rPr lang="en-US" smtClean="0"/>
               <a:t>Fifth level</a:t>
             </a:r>
+            <a:endParaRPr lang="en-US"/>
           </a:p>
         </p:txBody>
       </p:sp>
@@ -817,7 +809,7 @@
           <a:p>
             <a:fld id="{5BCAD085-E8A6-8845-BD4E-CB4CCA059FC4}" type="datetimeFigureOut">
               <a:rPr lang="en-US" smtClean="0"/>
-              <a:t>4/4/26</a:t>
+              <a:t>1/27/13</a:t>
             </a:fld>
             <a:endParaRPr lang="en-US"/>
           </a:p>
@@ -920,9 +912,10 @@
           </a:lstStyle>
           <a:p>
             <a:r>
-              <a:rPr lang="en-US"/>
+              <a:rPr lang="en-US" smtClean="0"/>
               <a:t>Click to edit Master title style</a:t>
             </a:r>
+            <a:endParaRPr lang="en-US"/>
           </a:p>
         </p:txBody>
       </p:sp>
@@ -1039,7 +1032,7 @@
           <a:p>
             <a:pPr lvl="0"/>
             <a:r>
-              <a:rPr lang="en-US"/>
+              <a:rPr lang="en-US" smtClean="0"/>
               <a:t>Click to edit Master text styles</a:t>
             </a:r>
           </a:p>
@@ -1062,7 +1055,7 @@
           <a:p>
             <a:fld id="{5BCAD085-E8A6-8845-BD4E-CB4CCA059FC4}" type="datetimeFigureOut">
               <a:rPr lang="en-US" smtClean="0"/>
-              <a:t>4/4/26</a:t>
+              <a:t>1/27/13</a:t>
             </a:fld>
             <a:endParaRPr lang="en-US"/>
           </a:p>
@@ -1156,9 +1149,10 @@
           <a:lstStyle/>
           <a:p>
             <a:r>
-              <a:rPr lang="en-US"/>
+              <a:rPr lang="en-US" smtClean="0"/>
               <a:t>Click to edit Master title style</a:t>
             </a:r>
+            <a:endParaRPr lang="en-US"/>
           </a:p>
         </p:txBody>
       </p:sp>
@@ -1212,37 +1206,38 @@
           <a:p>
             <a:pPr lvl="0"/>
             <a:r>
-              <a:rPr lang="en-US"/>
+              <a:rPr lang="en-US" smtClean="0"/>
               <a:t>Click to edit Master text styles</a:t>
             </a:r>
           </a:p>
           <a:p>
             <a:pPr lvl="1"/>
             <a:r>
-              <a:rPr lang="en-US"/>
+              <a:rPr lang="en-US" smtClean="0"/>
               <a:t>Second level</a:t>
             </a:r>
           </a:p>
           <a:p>
             <a:pPr lvl="2"/>
             <a:r>
-              <a:rPr lang="en-US"/>
+              <a:rPr lang="en-US" smtClean="0"/>
               <a:t>Third level</a:t>
             </a:r>
           </a:p>
           <a:p>
             <a:pPr lvl="3"/>
             <a:r>
-              <a:rPr lang="en-US"/>
+              <a:rPr lang="en-US" smtClean="0"/>
               <a:t>Fourth level</a:t>
             </a:r>
           </a:p>
           <a:p>
             <a:pPr lvl="4"/>
             <a:r>
-              <a:rPr lang="en-US"/>
+              <a:rPr lang="en-US" smtClean="0"/>
               <a:t>Fifth level</a:t>
             </a:r>
+            <a:endParaRPr lang="en-US"/>
           </a:p>
         </p:txBody>
       </p:sp>
@@ -1296,37 +1291,38 @@
           <a:p>
             <a:pPr lvl="0"/>
             <a:r>
-              <a:rPr lang="en-US"/>
+              <a:rPr lang="en-US" smtClean="0"/>
               <a:t>Click to edit Master text styles</a:t>
             </a:r>
           </a:p>
           <a:p>
             <a:pPr lvl="1"/>
             <a:r>
-              <a:rPr lang="en-US"/>
+              <a:rPr lang="en-US" smtClean="0"/>
               <a:t>Second level</a:t>
             </a:r>
           </a:p>
           <a:p>
             <a:pPr lvl="2"/>
             <a:r>
-              <a:rPr lang="en-US"/>
+              <a:rPr lang="en-US" smtClean="0"/>
               <a:t>Third level</a:t>
             </a:r>
           </a:p>
           <a:p>
             <a:pPr lvl="3"/>
             <a:r>
-              <a:rPr lang="en-US"/>
+              <a:rPr lang="en-US" smtClean="0"/>
               <a:t>Fourth level</a:t>
             </a:r>
           </a:p>
           <a:p>
             <a:pPr lvl="4"/>
             <a:r>
-              <a:rPr lang="en-US"/>
+              <a:rPr lang="en-US" smtClean="0"/>
               <a:t>Fifth level</a:t>
             </a:r>
+            <a:endParaRPr lang="en-US"/>
           </a:p>
         </p:txBody>
       </p:sp>
@@ -1347,7 +1343,7 @@
           <a:p>
             <a:fld id="{5BCAD085-E8A6-8845-BD4E-CB4CCA059FC4}" type="datetimeFigureOut">
               <a:rPr lang="en-US" smtClean="0"/>
-              <a:t>4/4/26</a:t>
+              <a:t>1/27/13</a:t>
             </a:fld>
             <a:endParaRPr lang="en-US"/>
           </a:p>
@@ -1445,9 +1441,10 @@
           </a:lstStyle>
           <a:p>
             <a:r>
-              <a:rPr lang="en-US"/>
+              <a:rPr lang="en-US" smtClean="0"/>
               <a:t>Click to edit Master title style</a:t>
             </a:r>
+            <a:endParaRPr lang="en-US"/>
           </a:p>
         </p:txBody>
       </p:sp>
@@ -1510,7 +1507,7 @@
           <a:p>
             <a:pPr lvl="0"/>
             <a:r>
-              <a:rPr lang="en-US"/>
+              <a:rPr lang="en-US" smtClean="0"/>
               <a:t>Click to edit Master text styles</a:t>
             </a:r>
           </a:p>
@@ -1566,37 +1563,38 @@
           <a:p>
             <a:pPr lvl="0"/>
             <a:r>
-              <a:rPr lang="en-US"/>
+              <a:rPr lang="en-US" smtClean="0"/>
               <a:t>Click to edit Master text styles</a:t>
             </a:r>
           </a:p>
           <a:p>
             <a:pPr lvl="1"/>
             <a:r>
-              <a:rPr lang="en-US"/>
+              <a:rPr lang="en-US" smtClean="0"/>
               <a:t>Second level</a:t>
             </a:r>
           </a:p>
           <a:p>
             <a:pPr lvl="2"/>
             <a:r>
-              <a:rPr lang="en-US"/>
+              <a:rPr lang="en-US" smtClean="0"/>
               <a:t>Third level</a:t>
             </a:r>
           </a:p>
           <a:p>
             <a:pPr lvl="3"/>
             <a:r>
-              <a:rPr lang="en-US"/>
+              <a:rPr lang="en-US" smtClean="0"/>
               <a:t>Fourth level</a:t>
             </a:r>
           </a:p>
           <a:p>
             <a:pPr lvl="4"/>
             <a:r>
-              <a:rPr lang="en-US"/>
+              <a:rPr lang="en-US" smtClean="0"/>
               <a:t>Fifth level</a:t>
             </a:r>
+            <a:endParaRPr lang="en-US"/>
           </a:p>
         </p:txBody>
       </p:sp>
@@ -1659,7 +1657,7 @@
           <a:p>
             <a:pPr lvl="0"/>
             <a:r>
-              <a:rPr lang="en-US"/>
+              <a:rPr lang="en-US" smtClean="0"/>
               <a:t>Click to edit Master text styles</a:t>
             </a:r>
           </a:p>
@@ -1715,37 +1713,38 @@
           <a:p>
             <a:pPr lvl="0"/>
             <a:r>
-              <a:rPr lang="en-US"/>
+              <a:rPr lang="en-US" smtClean="0"/>
               <a:t>Click to edit Master text styles</a:t>
             </a:r>
           </a:p>
           <a:p>
             <a:pPr lvl="1"/>
             <a:r>
-              <a:rPr lang="en-US"/>
+              <a:rPr lang="en-US" smtClean="0"/>
               <a:t>Second level</a:t>
             </a:r>
           </a:p>
           <a:p>
             <a:pPr lvl="2"/>
             <a:r>
-              <a:rPr lang="en-US"/>
+              <a:rPr lang="en-US" smtClean="0"/>
               <a:t>Third level</a:t>
             </a:r>
           </a:p>
           <a:p>
             <a:pPr lvl="3"/>
             <a:r>
-              <a:rPr lang="en-US"/>
+              <a:rPr lang="en-US" smtClean="0"/>
               <a:t>Fourth level</a:t>
             </a:r>
           </a:p>
           <a:p>
             <a:pPr lvl="4"/>
             <a:r>
-              <a:rPr lang="en-US"/>
+              <a:rPr lang="en-US" smtClean="0"/>
               <a:t>Fifth level</a:t>
             </a:r>
+            <a:endParaRPr lang="en-US"/>
           </a:p>
         </p:txBody>
       </p:sp>
@@ -1766,7 +1765,7 @@
           <a:p>
             <a:fld id="{5BCAD085-E8A6-8845-BD4E-CB4CCA059FC4}" type="datetimeFigureOut">
               <a:rPr lang="en-US" smtClean="0"/>
-              <a:t>4/4/26</a:t>
+              <a:t>1/27/13</a:t>
             </a:fld>
             <a:endParaRPr lang="en-US"/>
           </a:p>
@@ -1860,9 +1859,10 @@
           <a:lstStyle/>
           <a:p>
             <a:r>
-              <a:rPr lang="en-US"/>
+              <a:rPr lang="en-US" smtClean="0"/>
               <a:t>Click to edit Master title style</a:t>
             </a:r>
+            <a:endParaRPr lang="en-US"/>
           </a:p>
         </p:txBody>
       </p:sp>
@@ -1883,7 +1883,7 @@
           <a:p>
             <a:fld id="{5BCAD085-E8A6-8845-BD4E-CB4CCA059FC4}" type="datetimeFigureOut">
               <a:rPr lang="en-US" smtClean="0"/>
-              <a:t>4/4/26</a:t>
+              <a:t>1/27/13</a:t>
             </a:fld>
             <a:endParaRPr lang="en-US"/>
           </a:p>
@@ -1978,7 +1978,7 @@
           <a:p>
             <a:fld id="{5BCAD085-E8A6-8845-BD4E-CB4CCA059FC4}" type="datetimeFigureOut">
               <a:rPr lang="en-US" smtClean="0"/>
-              <a:t>4/4/26</a:t>
+              <a:t>1/27/13</a:t>
             </a:fld>
             <a:endParaRPr lang="en-US"/>
           </a:p>
@@ -2081,9 +2081,10 @@
           </a:lstStyle>
           <a:p>
             <a:r>
-              <a:rPr lang="en-US"/>
+              <a:rPr lang="en-US" smtClean="0"/>
               <a:t>Click to edit Master title style</a:t>
             </a:r>
+            <a:endParaRPr lang="en-US"/>
           </a:p>
         </p:txBody>
       </p:sp>
@@ -2137,37 +2138,38 @@
           <a:p>
             <a:pPr lvl="0"/>
             <a:r>
-              <a:rPr lang="en-US"/>
+              <a:rPr lang="en-US" smtClean="0"/>
               <a:t>Click to edit Master text styles</a:t>
             </a:r>
           </a:p>
           <a:p>
             <a:pPr lvl="1"/>
             <a:r>
-              <a:rPr lang="en-US"/>
+              <a:rPr lang="en-US" smtClean="0"/>
               <a:t>Second level</a:t>
             </a:r>
           </a:p>
           <a:p>
             <a:pPr lvl="2"/>
             <a:r>
-              <a:rPr lang="en-US"/>
+              <a:rPr lang="en-US" smtClean="0"/>
               <a:t>Third level</a:t>
             </a:r>
           </a:p>
           <a:p>
             <a:pPr lvl="3"/>
             <a:r>
-              <a:rPr lang="en-US"/>
+              <a:rPr lang="en-US" smtClean="0"/>
               <a:t>Fourth level</a:t>
             </a:r>
           </a:p>
           <a:p>
             <a:pPr lvl="4"/>
             <a:r>
-              <a:rPr lang="en-US"/>
+              <a:rPr lang="en-US" smtClean="0"/>
               <a:t>Fifth level</a:t>
             </a:r>
+            <a:endParaRPr lang="en-US"/>
           </a:p>
         </p:txBody>
       </p:sp>
@@ -2230,7 +2232,7 @@
           <a:p>
             <a:pPr lvl="0"/>
             <a:r>
-              <a:rPr lang="en-US"/>
+              <a:rPr lang="en-US" smtClean="0"/>
               <a:t>Click to edit Master text styles</a:t>
             </a:r>
           </a:p>
@@ -2253,7 +2255,7 @@
           <a:p>
             <a:fld id="{5BCAD085-E8A6-8845-BD4E-CB4CCA059FC4}" type="datetimeFigureOut">
               <a:rPr lang="en-US" smtClean="0"/>
-              <a:t>4/4/26</a:t>
+              <a:t>1/27/13</a:t>
             </a:fld>
             <a:endParaRPr lang="en-US"/>
           </a:p>
@@ -2356,9 +2358,10 @@
           </a:lstStyle>
           <a:p>
             <a:r>
-              <a:rPr lang="en-US"/>
+              <a:rPr lang="en-US" smtClean="0"/>
               <a:t>Click to edit Master title style</a:t>
             </a:r>
+            <a:endParaRPr lang="en-US"/>
           </a:p>
         </p:txBody>
       </p:sp>
@@ -2482,7 +2485,7 @@
           <a:p>
             <a:pPr lvl="0"/>
             <a:r>
-              <a:rPr lang="en-US"/>
+              <a:rPr lang="en-US" smtClean="0"/>
               <a:t>Click to edit Master text styles</a:t>
             </a:r>
           </a:p>
@@ -2505,7 +2508,7 @@
           <a:p>
             <a:fld id="{5BCAD085-E8A6-8845-BD4E-CB4CCA059FC4}" type="datetimeFigureOut">
               <a:rPr lang="en-US" smtClean="0"/>
-              <a:t>4/4/26</a:t>
+              <a:t>1/27/13</a:t>
             </a:fld>
             <a:endParaRPr lang="en-US"/>
           </a:p>
@@ -2614,9 +2617,10 @@
           <a:lstStyle/>
           <a:p>
             <a:r>
-              <a:rPr lang="en-US"/>
+              <a:rPr lang="en-US" smtClean="0"/>
               <a:t>Click to edit Master title style</a:t>
             </a:r>
+            <a:endParaRPr lang="en-US"/>
           </a:p>
         </p:txBody>
       </p:sp>
@@ -2647,37 +2651,38 @@
           <a:p>
             <a:pPr lvl="0"/>
             <a:r>
-              <a:rPr lang="en-US"/>
+              <a:rPr lang="en-US" smtClean="0"/>
               <a:t>Click to edit Master text styles</a:t>
             </a:r>
           </a:p>
           <a:p>
             <a:pPr lvl="1"/>
             <a:r>
-              <a:rPr lang="en-US"/>
+              <a:rPr lang="en-US" smtClean="0"/>
               <a:t>Second level</a:t>
             </a:r>
           </a:p>
           <a:p>
             <a:pPr lvl="2"/>
             <a:r>
-              <a:rPr lang="en-US"/>
+              <a:rPr lang="en-US" smtClean="0"/>
               <a:t>Third level</a:t>
             </a:r>
           </a:p>
           <a:p>
             <a:pPr lvl="3"/>
             <a:r>
-              <a:rPr lang="en-US"/>
+              <a:rPr lang="en-US" smtClean="0"/>
               <a:t>Fourth level</a:t>
             </a:r>
           </a:p>
           <a:p>
             <a:pPr lvl="4"/>
             <a:r>
-              <a:rPr lang="en-US"/>
+              <a:rPr lang="en-US" smtClean="0"/>
               <a:t>Fifth level</a:t>
             </a:r>
+            <a:endParaRPr lang="en-US"/>
           </a:p>
         </p:txBody>
       </p:sp>
@@ -2716,7 +2721,7 @@
           <a:p>
             <a:fld id="{5BCAD085-E8A6-8845-BD4E-CB4CCA059FC4}" type="datetimeFigureOut">
               <a:rPr lang="en-US" smtClean="0"/>
-              <a:t>4/4/26</a:t>
+              <a:t>1/27/13</a:t>
             </a:fld>
             <a:endParaRPr lang="en-US"/>
           </a:p>
@@ -3075,7 +3080,7 @@
 </file>
 
 <file path=ppt/slides/slide1.xml><?xml version="1.0" encoding="utf-8"?>
-<p:sld xmlns:a="http://schemas.openxmlformats.org/drawingml/2006/main" xmlns:r="http://schemas.openxmlformats.org/officeDocument/2006/relationships" xmlns:p="http://schemas.openxmlformats.org/presentationml/2006/main">
+<p:sld xmlns:a="http://schemas.openxmlformats.org/drawingml/2006/main" xmlns:p="http://schemas.openxmlformats.org/presentationml/2006/main" xmlns:r="http://schemas.openxmlformats.org/officeDocument/2006/relationships">
   <p:cSld>
     <p:bg>
       <p:bgPr>
@@ -3091,14 +3096,7 @@
         <p:cNvGrpSpPr/>
         <p:nvPr/>
       </p:nvGrpSpPr>
-      <p:grpSpPr>
-        <a:xfrm>
-          <a:off x="0" y="0"/>
-          <a:ext cx="0" cy="0"/>
-          <a:chOff x="0" y="0"/>
-          <a:chExt cx="0" cy="0"/>
-        </a:xfrm>
-      </p:grpSpPr>
+      <p:grpSpPr/>
       <p:sp>
         <p:nvSpPr>
           <p:cNvPr id="2" name="TextBox 1"/>
@@ -3288,7 +3286,6 @@
           <a:lstStyle/>
           <a:p>
             <a:pPr algn="ctr"/>
-            <a:endParaRPr/>
           </a:p>
         </p:txBody>
       </p:sp>
@@ -3326,7 +3323,6 @@
               </a:defRPr>
             </a:pPr>
             <a:r>
-              <a:rPr dirty="0"/>
               <a:t>Multi-Source Sentiment Spillover Network × Post-Earnings Prediction</a:t>
             </a:r>
           </a:p>
@@ -3343,7 +3339,6 @@
               </a:defRPr>
             </a:pPr>
             <a:r>
-              <a:rPr dirty="0"/>
               <a:t>Magnificent 7: AAPL · MSFT · GOOGL · AMZN · NVDA · META · TSLA</a:t>
             </a:r>
           </a:p>
@@ -3360,7 +3355,6 @@
               </a:defRPr>
             </a:pPr>
             <a:r>
-              <a:rPr dirty="0"/>
               <a:t>91 Earnings Events  ·  2022 Q1 – 2025 Q1  ·  5 Progressive Models</a:t>
             </a:r>
           </a:p>
@@ -3374,7 +3368,7 @@
         </p:nvSpPr>
         <p:spPr>
           <a:xfrm>
-            <a:off x="914400" y="6583680"/>
+            <a:off x="914400" y="6217920"/>
             <a:ext cx="2103120" cy="411480"/>
           </a:xfrm>
           <a:prstGeom prst="rect">
@@ -3408,7 +3402,6 @@
           <a:lstStyle/>
           <a:p>
             <a:pPr algn="ctr"/>
-            <a:endParaRPr/>
           </a:p>
         </p:txBody>
       </p:sp>
@@ -3420,7 +3413,7 @@
         </p:nvSpPr>
         <p:spPr>
           <a:xfrm>
-            <a:off x="914400" y="6629400"/>
+            <a:off x="914400" y="6236208"/>
             <a:ext cx="2103120" cy="411480"/>
           </a:xfrm>
           <a:prstGeom prst="rect">
@@ -3453,7 +3446,46 @@
       </p:sp>
       <p:sp>
         <p:nvSpPr>
-          <p:cNvPr id="9" name="Rectangle 8"/>
+          <p:cNvPr id="9" name="TextBox 8"/>
+          <p:cNvSpPr txBox="1"/>
+          <p:nvPr/>
+        </p:nvSpPr>
+        <p:spPr>
+          <a:xfrm>
+            <a:off x="914400" y="6858000"/>
+            <a:ext cx="9144000" cy="457200"/>
+          </a:xfrm>
+          <a:prstGeom prst="rect">
+            <a:avLst/>
+          </a:prstGeom>
+          <a:noFill/>
+        </p:spPr>
+        <p:txBody>
+          <a:bodyPr wrap="square">
+            <a:spAutoFit/>
+          </a:bodyPr>
+          <a:lstStyle/>
+          <a:p>
+            <a:pPr algn="l">
+              <a:lnSpc>
+                <a:spcPts val="1920"/>
+              </a:lnSpc>
+              <a:defRPr sz="1600" b="0">
+                <a:solidFill>
+                  <a:srgbClr val="A1A1AA"/>
+                </a:solidFill>
+                <a:latin typeface="Inter"/>
+              </a:defRPr>
+            </a:pPr>
+            <a:r>
+              <a:t>Tu Le  ·  Yixin Wei  ·  Ernesto Aguilar</a:t>
+            </a:r>
+          </a:p>
+        </p:txBody>
+      </p:sp>
+      <p:sp>
+        <p:nvSpPr>
+          <p:cNvPr id="10" name="Rectangle 9"/>
           <p:cNvSpPr/>
           <p:nvPr/>
         </p:nvSpPr>
@@ -3491,7 +3523,6 @@
           <a:lstStyle/>
           <a:p>
             <a:pPr algn="ctr"/>
-            <a:endParaRPr/>
           </a:p>
         </p:txBody>
       </p:sp>
@@ -3504,7 +3535,7 @@
 </file>
 
 <file path=ppt/slides/slide2.xml><?xml version="1.0" encoding="utf-8"?>
-<p:sld xmlns:a="http://schemas.openxmlformats.org/drawingml/2006/main" xmlns:r="http://schemas.openxmlformats.org/officeDocument/2006/relationships" xmlns:p="http://schemas.openxmlformats.org/presentationml/2006/main">
+<p:sld xmlns:a="http://schemas.openxmlformats.org/drawingml/2006/main" xmlns:p="http://schemas.openxmlformats.org/presentationml/2006/main" xmlns:r="http://schemas.openxmlformats.org/officeDocument/2006/relationships">
   <p:cSld>
     <p:bg>
       <p:bgPr>
@@ -3520,14 +3551,7 @@
         <p:cNvGrpSpPr/>
         <p:nvPr/>
       </p:nvGrpSpPr>
-      <p:grpSpPr>
-        <a:xfrm>
-          <a:off x="0" y="0"/>
-          <a:ext cx="0" cy="0"/>
-          <a:chOff x="0" y="0"/>
-          <a:chExt cx="0" cy="0"/>
-        </a:xfrm>
-      </p:grpSpPr>
+      <p:grpSpPr/>
       <p:sp>
         <p:nvSpPr>
           <p:cNvPr id="2" name="TextBox 1"/>
@@ -3678,7 +3702,6 @@
           <a:lstStyle/>
           <a:p>
             <a:pPr algn="ctr"/>
-            <a:endParaRPr/>
           </a:p>
         </p:txBody>
       </p:sp>
@@ -3779,7 +3802,6 @@
           <a:lstStyle/>
           <a:p>
             <a:pPr algn="ctr"/>
-            <a:endParaRPr/>
           </a:p>
         </p:txBody>
       </p:sp>
@@ -3917,7 +3939,6 @@
           <a:lstStyle/>
           <a:p>
             <a:pPr algn="ctr"/>
-            <a:endParaRPr/>
           </a:p>
         </p:txBody>
       </p:sp>
@@ -4055,7 +4076,6 @@
           <a:lstStyle/>
           <a:p>
             <a:pPr algn="ctr"/>
-            <a:endParaRPr/>
           </a:p>
         </p:txBody>
       </p:sp>
@@ -4193,7 +4213,6 @@
           <a:lstStyle/>
           <a:p>
             <a:pPr algn="ctr"/>
-            <a:endParaRPr/>
           </a:p>
         </p:txBody>
       </p:sp>

</xml_diff>